<commit_message>
Update project title and checkpoint Chinese presentation figures
</commit_message>
<xml_diff>
--- a/outputs/submission/DOEF_Competition_Presentation.pptx
+++ b/outputs/submission/DOEF_Competition_Presentation.pptx
@@ -3208,7 +3208,7 @@
                 <a:ea typeface="Arial"/>
                 <a:cs typeface="Arial"/>
               </a:rPr>
-              <a:t>DOEF</a:t>
+              <a:t>智能云储</a:t>
             </a:r>
             <a:endParaRPr sz="4900"/>
           </a:p>
@@ -3251,7 +3251,7 @@
               <a:buNone/>
             </a:pPr>
             <a:r>
-              <a:rPr sz="3400" b="1">
+              <a:rPr sz="2600" b="1">
                 <a:solidFill>
                   <a:srgbClr val="F8FBFF"/>
                 </a:solidFill>
@@ -3259,7 +3259,7 @@
                 <a:ea typeface="Microsoft YaHei"/>
                 <a:cs typeface="Microsoft YaHei"/>
               </a:rPr>
-              <a:t>让负荷预测服务于</a:t>
+              <a:t>基于决策导向预测融合的</a:t>
             </a:r>
             <a:endParaRPr sz="3400"/>
           </a:p>
@@ -3271,7 +3271,7 @@
               <a:buNone/>
             </a:pPr>
             <a:r>
-              <a:rPr sz="3400" b="1">
+              <a:rPr sz="2600" b="1">
                 <a:solidFill>
                   <a:srgbClr val="F8FBFF"/>
                 </a:solidFill>
@@ -3279,7 +3279,7 @@
                 <a:ea typeface="Microsoft YaHei"/>
                 <a:cs typeface="Microsoft YaHei"/>
               </a:rPr>
-              <a:t>储能削峰决策</a:t>
+              <a:t>建筑储能削峰优化系统</a:t>
             </a:r>
             <a:endParaRPr sz="3400"/>
           </a:p>
@@ -4465,7 +4465,7 @@
                 <a:ea typeface="Microsoft YaHei"/>
                 <a:cs typeface="Microsoft YaHei"/>
               </a:rPr>
-              <a:t>智储云控 · DOEF | 8 栋办公建筑仿真实验</a:t>
+              <a:t>智能云储 · DOEF | 8 栋办公建筑仿真实验</a:t>
             </a:r>
             <a:endParaRPr sz="750"/>
           </a:p>
@@ -5883,7 +5883,7 @@
                 <a:ea typeface="Microsoft YaHei"/>
                 <a:cs typeface="Microsoft YaHei"/>
               </a:rPr>
-              <a:t>智储云控 · DOEF | 8 栋办公建筑仿真实验</a:t>
+              <a:t>智能云储 · DOEF | 8 栋办公建筑仿真实验</a:t>
             </a:r>
             <a:endParaRPr sz="750"/>
           </a:p>
@@ -6307,7 +6307,7 @@
                 <a:ea typeface="Microsoft YaHei"/>
                 <a:cs typeface="Microsoft YaHei"/>
               </a:rPr>
-              <a:t>智储云控 · DOEF | 8 栋办公建筑仿真实验</a:t>
+              <a:t>智能云储 · DOEF | 8 栋办公建筑仿真实验</a:t>
             </a:r>
             <a:endParaRPr sz="750"/>
           </a:p>
@@ -7332,7 +7332,7 @@
                 <a:ea typeface="Microsoft YaHei"/>
                 <a:cs typeface="Microsoft YaHei"/>
               </a:rPr>
-              <a:t>智储云控 · DOEF | 8 栋办公建筑仿真实验</a:t>
+              <a:t>智能云储 · DOEF | 8 栋办公建筑仿真实验</a:t>
             </a:r>
             <a:endParaRPr sz="750"/>
           </a:p>
@@ -9446,7 +9446,7 @@
                 <a:ea typeface="Microsoft YaHei"/>
                 <a:cs typeface="Microsoft YaHei"/>
               </a:rPr>
-              <a:t>智储云控 · DOEF | 补充实验与方法说明</a:t>
+              <a:t>智能云储 · DOEF | 补充实验与方法说明</a:t>
             </a:r>
             <a:endParaRPr sz="750"/>
           </a:p>
@@ -10351,7 +10351,7 @@
                 <a:ea typeface="Microsoft YaHei"/>
                 <a:cs typeface="Microsoft YaHei"/>
               </a:rPr>
-              <a:t>智储云控 · DOEF | 补充实验与方法说明</a:t>
+              <a:t>智能云储 · DOEF | 补充实验与方法说明</a:t>
             </a:r>
             <a:endParaRPr sz="750"/>
           </a:p>
@@ -13702,7 +13702,7 @@
                 <a:ea typeface="Microsoft YaHei"/>
                 <a:cs typeface="Microsoft YaHei"/>
               </a:rPr>
-              <a:t>智储云控 · DOEF | 补充实验与方法说明</a:t>
+              <a:t>智能云储 · DOEF | 补充实验与方法说明</a:t>
             </a:r>
             <a:endParaRPr sz="750"/>
           </a:p>
@@ -15322,7 +15322,7 @@
                 <a:ea typeface="Microsoft YaHei"/>
                 <a:cs typeface="Microsoft YaHei"/>
               </a:rPr>
-              <a:t>智储云控 · DOEF | 补充实验与方法说明</a:t>
+              <a:t>智能云储 · DOEF | 补充实验与方法说明</a:t>
             </a:r>
             <a:endParaRPr sz="750"/>
           </a:p>
@@ -19410,7 +19410,7 @@
                 <a:ea typeface="Microsoft YaHei"/>
                 <a:cs typeface="Microsoft YaHei"/>
               </a:rPr>
-              <a:t>智储云控 · DOEF | 补充实验与方法说明</a:t>
+              <a:t>智能云储 · DOEF | 补充实验与方法说明</a:t>
             </a:r>
             <a:endParaRPr sz="750"/>
           </a:p>
@@ -22330,7 +22330,7 @@
                 <a:ea typeface="Microsoft YaHei"/>
                 <a:cs typeface="Microsoft YaHei"/>
               </a:rPr>
-              <a:t>智储云控 · DOEF | 补充实验与方法说明</a:t>
+              <a:t>智能云储 · DOEF | 补充实验与方法说明</a:t>
             </a:r>
             <a:endParaRPr sz="750"/>
           </a:p>
@@ -23270,7 +23270,7 @@
                 <a:ea typeface="Microsoft YaHei"/>
                 <a:cs typeface="Microsoft YaHei"/>
               </a:rPr>
-              <a:t>智储云控 · DOEF | 补充实验与方法说明</a:t>
+              <a:t>智能云储 · DOEF | 补充实验与方法说明</a:t>
             </a:r>
             <a:endParaRPr sz="750"/>
           </a:p>
@@ -24174,7 +24174,7 @@
                 <a:ea typeface="Microsoft YaHei"/>
                 <a:cs typeface="Microsoft YaHei"/>
               </a:rPr>
-              <a:t>智储云控 · DOEF | 8 栋办公建筑仿真实验</a:t>
+              <a:t>智能云储 · DOEF | 8 栋办公建筑仿真实验</a:t>
             </a:r>
             <a:endParaRPr sz="750"/>
           </a:p>
@@ -26907,7 +26907,7 @@
                 <a:ea typeface="Microsoft YaHei"/>
                 <a:cs typeface="Microsoft YaHei"/>
               </a:rPr>
-              <a:t>智储云控 · DOEF | 补充实验与方法说明</a:t>
+              <a:t>智能云储 · DOEF | 补充实验与方法说明</a:t>
             </a:r>
             <a:endParaRPr sz="750"/>
           </a:p>
@@ -28108,7 +28108,7 @@
                 <a:ea typeface="Microsoft YaHei"/>
                 <a:cs typeface="Microsoft YaHei"/>
               </a:rPr>
-              <a:t>智储云控 · DOEF | 补充实验与方法说明</a:t>
+              <a:t>智能云储 · DOEF | 补充实验与方法说明</a:t>
             </a:r>
             <a:endParaRPr sz="750"/>
           </a:p>
@@ -29202,7 +29202,7 @@
                 <a:ea typeface="Microsoft YaHei"/>
                 <a:cs typeface="Microsoft YaHei"/>
               </a:rPr>
-              <a:t>智储云控 · DOEF | 补充实验与方法说明</a:t>
+              <a:t>智能云储 · DOEF | 补充实验与方法说明</a:t>
             </a:r>
             <a:endParaRPr sz="750"/>
           </a:p>
@@ -30366,7 +30366,7 @@
                 <a:ea typeface="Microsoft YaHei"/>
                 <a:cs typeface="Microsoft YaHei"/>
               </a:rPr>
-              <a:t>智储云控 · DOEF | 补充实验与方法说明</a:t>
+              <a:t>智能云储 · DOEF | 补充实验与方法说明</a:t>
             </a:r>
             <a:endParaRPr sz="750"/>
           </a:p>
@@ -31004,7 +31004,7 @@
                 <a:ea typeface="Microsoft YaHei"/>
                 <a:cs typeface="Microsoft YaHei"/>
               </a:rPr>
-              <a:t>智储云控 · DOEF | 8 栋办公建筑仿真实验</a:t>
+              <a:t>智能云储 · DOEF | 8 栋办公建筑仿真实验</a:t>
             </a:r>
             <a:endParaRPr sz="750"/>
           </a:p>
@@ -32406,7 +32406,7 @@
                 <a:ea typeface="Microsoft YaHei"/>
                 <a:cs typeface="Microsoft YaHei"/>
               </a:rPr>
-              <a:t>智储云控 · DOEF | 8 栋办公建筑仿真实验</a:t>
+              <a:t>智能云储 · DOEF | 8 栋办公建筑仿真实验</a:t>
             </a:r>
             <a:endParaRPr sz="750"/>
           </a:p>
@@ -32830,7 +32830,7 @@
                 <a:ea typeface="Microsoft YaHei"/>
                 <a:cs typeface="Microsoft YaHei"/>
               </a:rPr>
-              <a:t>智储云控 · DOEF | 8 栋办公建筑仿真实验</a:t>
+              <a:t>智能云储 · DOEF | 8 栋办公建筑仿真实验</a:t>
             </a:r>
             <a:endParaRPr sz="750"/>
           </a:p>
@@ -33658,7 +33658,7 @@
                 <a:ea typeface="Microsoft YaHei"/>
                 <a:cs typeface="Microsoft YaHei"/>
               </a:rPr>
-              <a:t>智储云控 · DOEF | 8 栋办公建筑仿真实验</a:t>
+              <a:t>智能云储 · DOEF | 8 栋办公建筑仿真实验</a:t>
             </a:r>
             <a:endParaRPr sz="750"/>
           </a:p>
@@ -34688,7 +34688,7 @@
                 <a:ea typeface="Microsoft YaHei"/>
                 <a:cs typeface="Microsoft YaHei"/>
               </a:rPr>
-              <a:t>智储云控 · DOEF | 8 栋办公建筑仿真实验</a:t>
+              <a:t>智能云储 · DOEF | 8 栋办公建筑仿真实验</a:t>
             </a:r>
             <a:endParaRPr sz="750"/>
           </a:p>
@@ -35546,7 +35546,7 @@
                 <a:ea typeface="Microsoft YaHei"/>
                 <a:cs typeface="Microsoft YaHei"/>
               </a:rPr>
-              <a:t>智储云控 · DOEF | 8 栋办公建筑仿真实验</a:t>
+              <a:t>智能云储 · DOEF | 8 栋办公建筑仿真实验</a:t>
             </a:r>
             <a:endParaRPr sz="750"/>
           </a:p>
@@ -36442,7 +36442,7 @@
                 <a:ea typeface="Microsoft YaHei"/>
                 <a:cs typeface="Microsoft YaHei"/>
               </a:rPr>
-              <a:t>智储云控 · DOEF | 8 栋办公建筑仿真实验</a:t>
+              <a:t>智能云储 · DOEF | 8 栋办公建筑仿真实验</a:t>
             </a:r>
             <a:endParaRPr sz="750"/>
           </a:p>

</xml_diff>